<commit_message>
chore: restore CampusRAG branding and publish presentation handoff
</commit_message>
<xml_diff>
--- a/docs/chatbot_release_20261007/저학년의_반란_기능흐름도_(v1.0)_20260927.pptx
+++ b/docs/chatbot_release_20261007/저학년의_반란_기능흐름도_(v1.0)_20260927.pptx
@@ -478,7 +478,7 @@
               <a:buNone/>
             </a:pPr>
             <a:r>
-              <a:t>CampusMate 챗봇 전용 기능흐름도 v1.0 / 2026-09-27. 근거: docs/저학년의_반란_CampusMate_챗봇_PRD_v1.1_20260927.docx, frontend-web/src/App.tsx, backend/main.py, backend/schemas.py, core/rag.py. 실제 구현과 PRD를 기반으로 작성. 운영 배포 완료를 의미하지 않음. 개인 일정 및 인증 기능은 제외.</a:t>
+              <a:t>CampusRAG 챗봇 전용 기능흐름도 v1.0 / 2026-09-27. 근거: docs/저학년의_반란_CampusRAG_챗봇_PRD_v1.1_20260927.docx, frontend-web/src/App.tsx, backend/main.py, backend/schemas.py, core/rag.py. 실제 구현과 PRD를 기반으로 작성. 운영 배포 완료를 의미하지 않음. 개인 일정 및 인증 기능은 제외.</a:t>
             </a:r>
             <a:endParaRPr/>
           </a:p>
@@ -558,7 +558,7 @@
               <a:buNone/>
             </a:pPr>
             <a:r>
-              <a:t>CampusMate 챗봇 전용 기능흐름도 v1.0 / 2026-09-27. 근거: docs/저학년의_반란_CampusMate_챗봇_PRD_v1.1_20260927.docx, frontend-web/src/App.tsx, backend/main.py, backend/schemas.py, core/rag.py. 실제 구현과 PRD를 기반으로 작성. 운영 배포 완료를 의미하지 않음. 개인 일정 및 인증 기능은 제외.</a:t>
+              <a:t>CampusRAG 챗봇 전용 기능흐름도 v1.0 / 2026-09-27. 근거: docs/저학년의_반란_CampusRAG_챗봇_PRD_v1.1_20260927.docx, frontend-web/src/App.tsx, backend/main.py, backend/schemas.py, core/rag.py. 실제 구현과 PRD를 기반으로 작성. 운영 배포 완료를 의미하지 않음. 개인 일정 및 인증 기능은 제외.</a:t>
             </a:r>
             <a:endParaRPr/>
           </a:p>
@@ -638,7 +638,7 @@
               <a:buNone/>
             </a:pPr>
             <a:r>
-              <a:t>CampusMate 챗봇 전용 기능흐름도 v1.0 / 2026-09-27. 근거: docs/저학년의_반란_CampusMate_챗봇_PRD_v1.1_20260927.docx, frontend-web/src/App.tsx, backend/main.py, backend/schemas.py, core/rag.py. 실제 구현과 PRD를 기반으로 작성. 운영 배포 완료를 의미하지 않음. 개인 일정 및 인증 기능은 제외.</a:t>
+              <a:t>CampusRAG 챗봇 전용 기능흐름도 v1.0 / 2026-09-27. 근거: docs/저학년의_반란_CampusRAG_챗봇_PRD_v1.1_20260927.docx, frontend-web/src/App.tsx, backend/main.py, backend/schemas.py, core/rag.py. 실제 구현과 PRD를 기반으로 작성. 운영 배포 완료를 의미하지 않음. 개인 일정 및 인증 기능은 제외.</a:t>
             </a:r>
             <a:endParaRPr/>
           </a:p>
@@ -718,7 +718,7 @@
               <a:buNone/>
             </a:pPr>
             <a:r>
-              <a:t>CampusMate 챗봇 전용 기능흐름도 v1.0 / 2026-09-27. 근거: docs/저학년의_반란_CampusMate_챗봇_PRD_v1.1_20260927.docx, frontend-web/src/App.tsx, backend/main.py, backend/schemas.py, core/rag.py. 실제 구현과 PRD를 기반으로 작성. 운영 배포 완료를 의미하지 않음. 개인 일정 및 인증 기능은 제외.</a:t>
+              <a:t>CampusRAG 챗봇 전용 기능흐름도 v1.0 / 2026-09-27. 근거: docs/저학년의_반란_CampusRAG_챗봇_PRD_v1.1_20260927.docx, frontend-web/src/App.tsx, backend/main.py, backend/schemas.py, core/rag.py. 실제 구현과 PRD를 기반으로 작성. 운영 배포 완료를 의미하지 않음. 개인 일정 및 인증 기능은 제외.</a:t>
             </a:r>
             <a:endParaRPr/>
           </a:p>
@@ -798,7 +798,7 @@
               <a:buNone/>
             </a:pPr>
             <a:r>
-              <a:t>CampusMate 챗봇 전용 기능흐름도 v1.0 / 2026-09-27. 근거: docs/저학년의_반란_CampusMate_챗봇_PRD_v1.1_20260927.docx, frontend-web/src/App.tsx, backend/main.py, backend/schemas.py, core/rag.py. 실제 구현과 PRD를 기반으로 작성. 운영 배포 완료를 의미하지 않음. 개인 일정 및 인증 기능은 제외.</a:t>
+              <a:t>CampusRAG 챗봇 전용 기능흐름도 v1.0 / 2026-09-27. 근거: docs/저학년의_반란_CampusRAG_챗봇_PRD_v1.1_20260927.docx, frontend-web/src/App.tsx, backend/main.py, backend/schemas.py, core/rag.py. 실제 구현과 PRD를 기반으로 작성. 운영 배포 완료를 의미하지 않음. 개인 일정 및 인증 기능은 제외.</a:t>
             </a:r>
             <a:endParaRPr/>
           </a:p>
@@ -2310,7 +2310,7 @@
                 <a:ea typeface="Malgun Gothic"/>
                 <a:cs typeface="Malgun Gothic"/>
               </a:rPr>
-              <a:t>CampusMate 기능흐름도 · 범위와 기호</a:t>
+              <a:t>CampusRAG 기능흐름도 · 범위와 기호</a:t>
             </a:r>
             <a:endParaRPr sz="1700" b="1" i="0" u="none" cap="none">
               <a:solidFill>
@@ -3366,7 +3366,7 @@
                 <a:ea typeface="Malgun Gothic"/>
                 <a:cs typeface="Malgun Gothic"/>
               </a:rPr>
-              <a:t>CampusMate 기능흐름도 · 전체</a:t>
+              <a:t>CampusRAG 기능흐름도 · 전체</a:t>
             </a:r>
             <a:endParaRPr sz="1700" b="1">
               <a:solidFill>
@@ -3635,7 +3635,7 @@
                 <a:ea typeface="Malgun Gothic"/>
                 <a:cs typeface="Malgun Gothic"/>
               </a:rPr>
-              <a:t>CampusMate 접속</a:t>
+              <a:t>CampusRAG 접속</a:t>
             </a:r>
           </a:p>
         </p:txBody>
@@ -4495,7 +4495,7 @@
                 <a:ea typeface="Malgun Gothic"/>
                 <a:cs typeface="Malgun Gothic"/>
               </a:rPr>
-              <a:t>CampusMate 기능흐름도 · 질문 입력</a:t>
+              <a:t>CampusRAG 기능흐름도 · 질문 입력</a:t>
             </a:r>
             <a:endParaRPr sz="1700" b="1">
               <a:solidFill>
@@ -5640,7 +5640,7 @@
                 <a:ea typeface="Malgun Gothic"/>
                 <a:cs typeface="Malgun Gothic"/>
               </a:rPr>
-              <a:t>CampusMate 기능흐름도 · 근거 검색과 답변</a:t>
+              <a:t>CampusRAG 기능흐름도 · 근거 검색과 답변</a:t>
             </a:r>
             <a:endParaRPr sz="1700" b="1">
               <a:solidFill>
@@ -6990,7 +6990,7 @@
                 <a:ea typeface="Malgun Gothic"/>
                 <a:cs typeface="Malgun Gothic"/>
               </a:rPr>
-              <a:t>CampusMate 기능흐름도 · 결과 확인과 예외</a:t>
+              <a:t>CampusRAG 기능흐름도 · 결과 확인과 예외</a:t>
             </a:r>
             <a:endParaRPr sz="1700" b="1">
               <a:solidFill>

</xml_diff>